<commit_message>
feat: Enhance debt graph functionality and improve candidate scoring
- Added VALIDATION_DEFAULT_IMPROVE_PATHOLOGICAL_SUCCESS to profile settings.
- Introduced build_debt_graph function to create a debt graph view, summarizing debt chains and structural intent.
- Updated CandidateScoring to include soft_penalty for better candidate evaluation.
- Enhanced candidate evaluation and sorting logic to prioritize lower soft penalties.
- Added tests for debt graph aggregation and candidate scoring improvements.
- Updated existing tests to reflect changes in timeout behavior and recovery strategies.
- Documented the move_candidates module for better understanding of candidate generation and filtering processes.
</commit_message>
<xml_diff>
--- a/现场布局图.pptx
+++ b/现场布局图.pptx
@@ -244,7 +244,7 @@
           <a:p>
             <a:fld id="{06F60DB7-6E48-4466-B7A9-24611520A472}" type="datetimeFigureOut">
               <a:rPr lang="zh-CN" altLang="en-US" smtClean="0"/>
-              <a:t>2026/5/12</a:t>
+              <a:t>2026/5/21</a:t>
             </a:fld>
             <a:endParaRPr lang="zh-CN" altLang="en-US"/>
           </a:p>
@@ -414,7 +414,7 @@
           <a:p>
             <a:fld id="{06F60DB7-6E48-4466-B7A9-24611520A472}" type="datetimeFigureOut">
               <a:rPr lang="zh-CN" altLang="en-US" smtClean="0"/>
-              <a:t>2026/5/12</a:t>
+              <a:t>2026/5/21</a:t>
             </a:fld>
             <a:endParaRPr lang="zh-CN" altLang="en-US"/>
           </a:p>
@@ -594,7 +594,7 @@
           <a:p>
             <a:fld id="{06F60DB7-6E48-4466-B7A9-24611520A472}" type="datetimeFigureOut">
               <a:rPr lang="zh-CN" altLang="en-US" smtClean="0"/>
-              <a:t>2026/5/12</a:t>
+              <a:t>2026/5/21</a:t>
             </a:fld>
             <a:endParaRPr lang="zh-CN" altLang="en-US"/>
           </a:p>
@@ -764,7 +764,7 @@
           <a:p>
             <a:fld id="{06F60DB7-6E48-4466-B7A9-24611520A472}" type="datetimeFigureOut">
               <a:rPr lang="zh-CN" altLang="en-US" smtClean="0"/>
-              <a:t>2026/5/12</a:t>
+              <a:t>2026/5/21</a:t>
             </a:fld>
             <a:endParaRPr lang="zh-CN" altLang="en-US"/>
           </a:p>
@@ -1010,7 +1010,7 @@
           <a:p>
             <a:fld id="{06F60DB7-6E48-4466-B7A9-24611520A472}" type="datetimeFigureOut">
               <a:rPr lang="zh-CN" altLang="en-US" smtClean="0"/>
-              <a:t>2026/5/12</a:t>
+              <a:t>2026/5/21</a:t>
             </a:fld>
             <a:endParaRPr lang="zh-CN" altLang="en-US"/>
           </a:p>
@@ -1242,7 +1242,7 @@
           <a:p>
             <a:fld id="{06F60DB7-6E48-4466-B7A9-24611520A472}" type="datetimeFigureOut">
               <a:rPr lang="zh-CN" altLang="en-US" smtClean="0"/>
-              <a:t>2026/5/12</a:t>
+              <a:t>2026/5/21</a:t>
             </a:fld>
             <a:endParaRPr lang="zh-CN" altLang="en-US"/>
           </a:p>
@@ -1609,7 +1609,7 @@
           <a:p>
             <a:fld id="{06F60DB7-6E48-4466-B7A9-24611520A472}" type="datetimeFigureOut">
               <a:rPr lang="zh-CN" altLang="en-US" smtClean="0"/>
-              <a:t>2026/5/12</a:t>
+              <a:t>2026/5/21</a:t>
             </a:fld>
             <a:endParaRPr lang="zh-CN" altLang="en-US"/>
           </a:p>
@@ -1727,7 +1727,7 @@
           <a:p>
             <a:fld id="{06F60DB7-6E48-4466-B7A9-24611520A472}" type="datetimeFigureOut">
               <a:rPr lang="zh-CN" altLang="en-US" smtClean="0"/>
-              <a:t>2026/5/12</a:t>
+              <a:t>2026/5/21</a:t>
             </a:fld>
             <a:endParaRPr lang="zh-CN" altLang="en-US"/>
           </a:p>
@@ -1822,7 +1822,7 @@
           <a:p>
             <a:fld id="{06F60DB7-6E48-4466-B7A9-24611520A472}" type="datetimeFigureOut">
               <a:rPr lang="zh-CN" altLang="en-US" smtClean="0"/>
-              <a:t>2026/5/12</a:t>
+              <a:t>2026/5/21</a:t>
             </a:fld>
             <a:endParaRPr lang="zh-CN" altLang="en-US"/>
           </a:p>
@@ -2099,7 +2099,7 @@
           <a:p>
             <a:fld id="{06F60DB7-6E48-4466-B7A9-24611520A472}" type="datetimeFigureOut">
               <a:rPr lang="zh-CN" altLang="en-US" smtClean="0"/>
-              <a:t>2026/5/12</a:t>
+              <a:t>2026/5/21</a:t>
             </a:fld>
             <a:endParaRPr lang="zh-CN" altLang="en-US"/>
           </a:p>
@@ -2356,7 +2356,7 @@
           <a:p>
             <a:fld id="{06F60DB7-6E48-4466-B7A9-24611520A472}" type="datetimeFigureOut">
               <a:rPr lang="zh-CN" altLang="en-US" smtClean="0"/>
-              <a:t>2026/5/12</a:t>
+              <a:t>2026/5/21</a:t>
             </a:fld>
             <a:endParaRPr lang="zh-CN" altLang="en-US"/>
           </a:p>
@@ -2569,7 +2569,7 @@
           <a:p>
             <a:fld id="{06F60DB7-6E48-4466-B7A9-24611520A472}" type="datetimeFigureOut">
               <a:rPr lang="zh-CN" altLang="en-US" smtClean="0"/>
-              <a:t>2026/5/12</a:t>
+              <a:t>2026/5/21</a:t>
             </a:fld>
             <a:endParaRPr lang="zh-CN" altLang="en-US"/>
           </a:p>
@@ -2982,7 +2982,7 @@
         </p:nvGrpSpPr>
         <p:grpSpPr>
           <a:xfrm>
-            <a:off x="927472" y="-205105"/>
+            <a:off x="942186" y="-205105"/>
             <a:ext cx="18896965" cy="7268210"/>
             <a:chOff x="-10106" y="-239"/>
             <a:chExt cx="29759" cy="11446"/>
@@ -6239,7 +6239,7 @@
           </p:nvSpPr>
           <p:spPr>
             <a:xfrm>
-              <a:off x="8151" y="5281"/>
+              <a:off x="8141" y="5418"/>
               <a:ext cx="962" cy="342"/>
             </a:xfrm>
             <a:custGeom>
@@ -15763,7 +15763,7 @@
           </p:nvSpPr>
           <p:spPr>
             <a:xfrm rot="18780000">
-              <a:off x="18140" y="2809"/>
+              <a:off x="18430" y="2722"/>
               <a:ext cx="808" cy="406"/>
             </a:xfrm>
             <a:custGeom>
@@ -19304,17 +19304,14 @@
                 </a:rPr>
                 <a:t>4</a:t>
               </a:r>
-              <a:r>
-                <a:rPr lang="zh-CN" altLang="en-US" sz="1000" b="1" dirty="0">
-                  <a:solidFill>
-                    <a:srgbClr val="191919"/>
-                  </a:solidFill>
-                  <a:latin typeface="微软雅黑" panose="020B0503020204020204" charset="-122"/>
-                  <a:ea typeface="微软雅黑" panose="020B0503020204020204" charset="-122"/>
-                  <a:cs typeface="微软雅黑" panose="020B0503020204020204" charset="-122"/>
-                </a:rPr>
-                <a:t>内</a:t>
-              </a:r>
+              <a:endParaRPr lang="zh-CN" altLang="en-US" sz="1000" b="1" dirty="0">
+                <a:solidFill>
+                  <a:srgbClr val="191919"/>
+                </a:solidFill>
+                <a:latin typeface="微软雅黑" panose="020B0503020204020204" charset="-122"/>
+                <a:ea typeface="微软雅黑" panose="020B0503020204020204" charset="-122"/>
+                <a:cs typeface="微软雅黑" panose="020B0503020204020204" charset="-122"/>
+              </a:endParaRPr>
             </a:p>
           </p:txBody>
         </p:sp>
@@ -19650,17 +19647,14 @@
                 </a:rPr>
                 <a:t>3</a:t>
               </a:r>
-              <a:r>
-                <a:rPr lang="zh-CN" altLang="en-US" sz="1000" b="1" dirty="0">
-                  <a:solidFill>
-                    <a:srgbClr val="191919"/>
-                  </a:solidFill>
-                  <a:latin typeface="微软雅黑" panose="020B0503020204020204" charset="-122"/>
-                  <a:ea typeface="微软雅黑" panose="020B0503020204020204" charset="-122"/>
-                  <a:cs typeface="微软雅黑" panose="020B0503020204020204" charset="-122"/>
-                </a:rPr>
-                <a:t>内</a:t>
-              </a:r>
+              <a:endParaRPr lang="zh-CN" altLang="en-US" sz="1000" b="1" dirty="0">
+                <a:solidFill>
+                  <a:srgbClr val="191919"/>
+                </a:solidFill>
+                <a:latin typeface="微软雅黑" panose="020B0503020204020204" charset="-122"/>
+                <a:ea typeface="微软雅黑" panose="020B0503020204020204" charset="-122"/>
+                <a:cs typeface="微软雅黑" panose="020B0503020204020204" charset="-122"/>
+              </a:endParaRPr>
             </a:p>
           </p:txBody>
         </p:sp>
@@ -19823,17 +19817,14 @@
                 </a:rPr>
                 <a:t>2</a:t>
               </a:r>
-              <a:r>
-                <a:rPr lang="zh-CN" altLang="en-US" sz="1000" b="1" dirty="0">
-                  <a:solidFill>
-                    <a:srgbClr val="191919"/>
-                  </a:solidFill>
-                  <a:latin typeface="微软雅黑" panose="020B0503020204020204" charset="-122"/>
-                  <a:ea typeface="微软雅黑" panose="020B0503020204020204" charset="-122"/>
-                  <a:cs typeface="微软雅黑" panose="020B0503020204020204" charset="-122"/>
-                </a:rPr>
-                <a:t>内</a:t>
-              </a:r>
+              <a:endParaRPr lang="zh-CN" altLang="en-US" sz="1000" b="1" dirty="0">
+                <a:solidFill>
+                  <a:srgbClr val="191919"/>
+                </a:solidFill>
+                <a:latin typeface="微软雅黑" panose="020B0503020204020204" charset="-122"/>
+                <a:ea typeface="微软雅黑" panose="020B0503020204020204" charset="-122"/>
+                <a:cs typeface="微软雅黑" panose="020B0503020204020204" charset="-122"/>
+              </a:endParaRPr>
             </a:p>
           </p:txBody>
         </p:sp>
@@ -19996,17 +19987,14 @@
                 </a:rPr>
                 <a:t>1</a:t>
               </a:r>
-              <a:r>
-                <a:rPr lang="zh-CN" altLang="en-US" sz="1000" b="1" dirty="0">
-                  <a:solidFill>
-                    <a:srgbClr val="191919"/>
-                  </a:solidFill>
-                  <a:latin typeface="微软雅黑" panose="020B0503020204020204" charset="-122"/>
-                  <a:ea typeface="微软雅黑" panose="020B0503020204020204" charset="-122"/>
-                  <a:cs typeface="微软雅黑" panose="020B0503020204020204" charset="-122"/>
-                </a:rPr>
-                <a:t>内</a:t>
-              </a:r>
+              <a:endParaRPr lang="zh-CN" altLang="en-US" sz="1000" b="1" dirty="0">
+                <a:solidFill>
+                  <a:srgbClr val="191919"/>
+                </a:solidFill>
+                <a:latin typeface="微软雅黑" panose="020B0503020204020204" charset="-122"/>
+                <a:ea typeface="微软雅黑" panose="020B0503020204020204" charset="-122"/>
+                <a:cs typeface="微软雅黑" panose="020B0503020204020204" charset="-122"/>
+              </a:endParaRPr>
             </a:p>
           </p:txBody>
         </p:sp>
@@ -24985,7 +24973,7 @@
                 <a:ea typeface="微软雅黑" panose="020B0503020204020204" charset="-122"/>
                 <a:cs typeface="微软雅黑" panose="020B0503020204020204" charset="-122"/>
               </a:rPr>
-              <a:t>190</a:t>
+              <a:t>68</a:t>
             </a:r>
             <a:r>
               <a:rPr lang="zh-CN" altLang="en-US" sz="685" dirty="0">
@@ -45635,17 +45623,14 @@
                 </a:rPr>
                 <a:t>4</a:t>
               </a:r>
-              <a:r>
-                <a:rPr lang="zh-CN" altLang="en-US" sz="1000" b="1" dirty="0">
-                  <a:solidFill>
-                    <a:srgbClr val="191919"/>
-                  </a:solidFill>
-                  <a:latin typeface="微软雅黑" panose="020B0503020204020204" charset="-122"/>
-                  <a:ea typeface="微软雅黑" panose="020B0503020204020204" charset="-122"/>
-                  <a:cs typeface="微软雅黑" panose="020B0503020204020204" charset="-122"/>
-                </a:rPr>
-                <a:t>内</a:t>
-              </a:r>
+              <a:endParaRPr lang="zh-CN" altLang="en-US" sz="1000" b="1" dirty="0">
+                <a:solidFill>
+                  <a:srgbClr val="191919"/>
+                </a:solidFill>
+                <a:latin typeface="微软雅黑" panose="020B0503020204020204" charset="-122"/>
+                <a:ea typeface="微软雅黑" panose="020B0503020204020204" charset="-122"/>
+                <a:cs typeface="微软雅黑" panose="020B0503020204020204" charset="-122"/>
+              </a:endParaRPr>
             </a:p>
           </p:txBody>
         </p:sp>
@@ -45993,17 +45978,14 @@
                 </a:rPr>
                 <a:t>3</a:t>
               </a:r>
-              <a:r>
-                <a:rPr lang="zh-CN" altLang="en-US" sz="1000" b="1" dirty="0">
-                  <a:solidFill>
-                    <a:srgbClr val="191919"/>
-                  </a:solidFill>
-                  <a:latin typeface="微软雅黑" panose="020B0503020204020204" charset="-122"/>
-                  <a:ea typeface="微软雅黑" panose="020B0503020204020204" charset="-122"/>
-                  <a:cs typeface="微软雅黑" panose="020B0503020204020204" charset="-122"/>
-                </a:rPr>
-                <a:t>内</a:t>
-              </a:r>
+              <a:endParaRPr lang="zh-CN" altLang="en-US" sz="1000" b="1" dirty="0">
+                <a:solidFill>
+                  <a:srgbClr val="191919"/>
+                </a:solidFill>
+                <a:latin typeface="微软雅黑" panose="020B0503020204020204" charset="-122"/>
+                <a:ea typeface="微软雅黑" panose="020B0503020204020204" charset="-122"/>
+                <a:cs typeface="微软雅黑" panose="020B0503020204020204" charset="-122"/>
+              </a:endParaRPr>
             </a:p>
           </p:txBody>
         </p:sp>

</xml_diff>

<commit_message>
chore: snapshot before phase1 hard cut
</commit_message>
<xml_diff>
--- a/现场布局图.pptx
+++ b/现场布局图.pptx
@@ -244,7 +244,7 @@
           <a:p>
             <a:fld id="{06F60DB7-6E48-4466-B7A9-24611520A472}" type="datetimeFigureOut">
               <a:rPr lang="zh-CN" altLang="en-US" smtClean="0"/>
-              <a:t>2026/5/23</a:t>
+              <a:t>2026/5/29</a:t>
             </a:fld>
             <a:endParaRPr lang="zh-CN" altLang="en-US"/>
           </a:p>
@@ -414,7 +414,7 @@
           <a:p>
             <a:fld id="{06F60DB7-6E48-4466-B7A9-24611520A472}" type="datetimeFigureOut">
               <a:rPr lang="zh-CN" altLang="en-US" smtClean="0"/>
-              <a:t>2026/5/23</a:t>
+              <a:t>2026/5/29</a:t>
             </a:fld>
             <a:endParaRPr lang="zh-CN" altLang="en-US"/>
           </a:p>
@@ -594,7 +594,7 @@
           <a:p>
             <a:fld id="{06F60DB7-6E48-4466-B7A9-24611520A472}" type="datetimeFigureOut">
               <a:rPr lang="zh-CN" altLang="en-US" smtClean="0"/>
-              <a:t>2026/5/23</a:t>
+              <a:t>2026/5/29</a:t>
             </a:fld>
             <a:endParaRPr lang="zh-CN" altLang="en-US"/>
           </a:p>
@@ -764,7 +764,7 @@
           <a:p>
             <a:fld id="{06F60DB7-6E48-4466-B7A9-24611520A472}" type="datetimeFigureOut">
               <a:rPr lang="zh-CN" altLang="en-US" smtClean="0"/>
-              <a:t>2026/5/23</a:t>
+              <a:t>2026/5/29</a:t>
             </a:fld>
             <a:endParaRPr lang="zh-CN" altLang="en-US"/>
           </a:p>
@@ -1010,7 +1010,7 @@
           <a:p>
             <a:fld id="{06F60DB7-6E48-4466-B7A9-24611520A472}" type="datetimeFigureOut">
               <a:rPr lang="zh-CN" altLang="en-US" smtClean="0"/>
-              <a:t>2026/5/23</a:t>
+              <a:t>2026/5/29</a:t>
             </a:fld>
             <a:endParaRPr lang="zh-CN" altLang="en-US"/>
           </a:p>
@@ -1242,7 +1242,7 @@
           <a:p>
             <a:fld id="{06F60DB7-6E48-4466-B7A9-24611520A472}" type="datetimeFigureOut">
               <a:rPr lang="zh-CN" altLang="en-US" smtClean="0"/>
-              <a:t>2026/5/23</a:t>
+              <a:t>2026/5/29</a:t>
             </a:fld>
             <a:endParaRPr lang="zh-CN" altLang="en-US"/>
           </a:p>
@@ -1609,7 +1609,7 @@
           <a:p>
             <a:fld id="{06F60DB7-6E48-4466-B7A9-24611520A472}" type="datetimeFigureOut">
               <a:rPr lang="zh-CN" altLang="en-US" smtClean="0"/>
-              <a:t>2026/5/23</a:t>
+              <a:t>2026/5/29</a:t>
             </a:fld>
             <a:endParaRPr lang="zh-CN" altLang="en-US"/>
           </a:p>
@@ -1727,7 +1727,7 @@
           <a:p>
             <a:fld id="{06F60DB7-6E48-4466-B7A9-24611520A472}" type="datetimeFigureOut">
               <a:rPr lang="zh-CN" altLang="en-US" smtClean="0"/>
-              <a:t>2026/5/23</a:t>
+              <a:t>2026/5/29</a:t>
             </a:fld>
             <a:endParaRPr lang="zh-CN" altLang="en-US"/>
           </a:p>
@@ -1822,7 +1822,7 @@
           <a:p>
             <a:fld id="{06F60DB7-6E48-4466-B7A9-24611520A472}" type="datetimeFigureOut">
               <a:rPr lang="zh-CN" altLang="en-US" smtClean="0"/>
-              <a:t>2026/5/23</a:t>
+              <a:t>2026/5/29</a:t>
             </a:fld>
             <a:endParaRPr lang="zh-CN" altLang="en-US"/>
           </a:p>
@@ -2099,7 +2099,7 @@
           <a:p>
             <a:fld id="{06F60DB7-6E48-4466-B7A9-24611520A472}" type="datetimeFigureOut">
               <a:rPr lang="zh-CN" altLang="en-US" smtClean="0"/>
-              <a:t>2026/5/23</a:t>
+              <a:t>2026/5/29</a:t>
             </a:fld>
             <a:endParaRPr lang="zh-CN" altLang="en-US"/>
           </a:p>
@@ -2356,7 +2356,7 @@
           <a:p>
             <a:fld id="{06F60DB7-6E48-4466-B7A9-24611520A472}" type="datetimeFigureOut">
               <a:rPr lang="zh-CN" altLang="en-US" smtClean="0"/>
-              <a:t>2026/5/23</a:t>
+              <a:t>2026/5/29</a:t>
             </a:fld>
             <a:endParaRPr lang="zh-CN" altLang="en-US"/>
           </a:p>
@@ -2569,7 +2569,7 @@
           <a:p>
             <a:fld id="{06F60DB7-6E48-4466-B7A9-24611520A472}" type="datetimeFigureOut">
               <a:rPr lang="zh-CN" altLang="en-US" smtClean="0"/>
-              <a:t>2026/5/23</a:t>
+              <a:t>2026/5/29</a:t>
             </a:fld>
             <a:endParaRPr lang="zh-CN" altLang="en-US"/>
           </a:p>

</xml_diff>